<commit_message>
fix: t2 slide3 extra textbox, slide6 remove idx6 from template
</commit_message>
<xml_diff>
--- a/templates/shablonlar/2.pptx
+++ b/templates/shablonlar/2.pptx
@@ -41188,44 +41188,6 @@
           </a:p>
         </p:txBody>
       </p:sp>
-      <p:sp>
-        <p:nvSpPr>
-          <p:cNvPr id="1200" name="Google Shape;1200;p47"/>
-          <p:cNvSpPr txBox="1">
-            <a:spLocks noGrp="1"/>
-          </p:cNvSpPr>
-          <p:nvPr>
-            <p:ph type="subTitle" idx="6"/>
-          </p:nvPr>
-        </p:nvSpPr>
-        <p:spPr>
-          <a:xfrm>
-            <a:off x="2464053" y="2960520"/>
-            <a:ext cx="5298033" cy="1494601"/>
-          </a:xfrm>
-          <a:prstGeom prst="rect">
-            <a:avLst/>
-          </a:prstGeom>
-        </p:spPr>
-        <p:txBody>
-          <a:bodyPr spcFirstLastPara="1" wrap="square" lIns="91425" tIns="91425" rIns="91425" bIns="91425" anchor="t" anchorCtr="0">
-            <a:noAutofit/>
-          </a:bodyPr>
-          <a:lstStyle/>
-          <a:p>
-            <a:pPr marL="0" lvl="0" indent="0" algn="l" rtl="0">
-              <a:spcBef>
-                <a:spcPts val="0"/>
-              </a:spcBef>
-              <a:spcAft>
-                <a:spcPts val="0"/>
-              </a:spcAft>
-              <a:buNone/>
-            </a:pPr>
-            <a:endParaRPr dirty="0"/>
-          </a:p>
-        </p:txBody>
-      </p:sp>
     </p:spTree>
   </p:cSld>
   <p:clrMapOvr>

</xml_diff>

<commit_message>
fix: remove rotated shape from t2 slide3 template and clean fill function
</commit_message>
<xml_diff>
--- a/templates/shablonlar/2.pptx
+++ b/templates/shablonlar/2.pptx
@@ -40219,57 +40219,6 @@
           </p:txBody>
         </p:sp>
       </p:grpSp>
-      <p:sp>
-        <p:nvSpPr>
-          <p:cNvPr id="1115" name="Google Shape;1115;p42"/>
-          <p:cNvSpPr/>
-          <p:nvPr/>
-        </p:nvSpPr>
-        <p:spPr>
-          <a:xfrm rot="10800000">
-            <a:off x="5857425" y="-78300"/>
-            <a:ext cx="3429000" cy="851400"/>
-          </a:xfrm>
-          <a:prstGeom prst="round1Rect">
-            <a:avLst>
-              <a:gd name="adj" fmla="val 16667"/>
-            </a:avLst>
-          </a:prstGeom>
-          <a:noFill/>
-          <a:ln w="9525" cap="flat" cmpd="sng">
-            <a:solidFill>
-              <a:schemeClr val="lt2"/>
-            </a:solidFill>
-            <a:prstDash val="solid"/>
-            <a:round/>
-            <a:headEnd type="none" w="sm" len="sm"/>
-            <a:tailEnd type="none" w="sm" len="sm"/>
-          </a:ln>
-        </p:spPr>
-        <p:txBody>
-          <a:bodyPr spcFirstLastPara="1" wrap="square" lIns="91425" tIns="91425" rIns="91425" bIns="91425" anchor="ctr" anchorCtr="0">
-            <a:noAutofit/>
-          </a:bodyPr>
-          <a:lstStyle/>
-          <a:p>
-            <a:pPr marL="0" lvl="0" indent="0" algn="ctr" rtl="0">
-              <a:spcBef>
-                <a:spcPts val="0"/>
-              </a:spcBef>
-              <a:spcAft>
-                <a:spcPts val="0"/>
-              </a:spcAft>
-              <a:buNone/>
-            </a:pPr>
-            <a:endParaRPr>
-              <a:latin typeface="Maven Pro"/>
-              <a:ea typeface="Maven Pro"/>
-              <a:cs typeface="Maven Pro"/>
-              <a:sym typeface="Maven Pro"/>
-            </a:endParaRPr>
-          </a:p>
-        </p:txBody>
-      </p:sp>
     </p:spTree>
   </p:cSld>
   <p:clrMapOvr>

</xml_diff>

<commit_message>
fix: t2 slide5 column spacing wider, col3 always filled, remove hyperlink styling
</commit_message>
<xml_diff>
--- a/templates/shablonlar/2.pptx
+++ b/templates/shablonlar/2.pptx
@@ -40219,6 +40219,57 @@
           </p:txBody>
         </p:sp>
       </p:grpSp>
+      <p:sp>
+        <p:nvSpPr>
+          <p:cNvPr id="1115" name="Google Shape;1115;p42"/>
+          <p:cNvSpPr/>
+          <p:nvPr/>
+        </p:nvSpPr>
+        <p:spPr>
+          <a:xfrm rot="10800000">
+            <a:off x="5857425" y="-78300"/>
+            <a:ext cx="3429000" cy="851400"/>
+          </a:xfrm>
+          <a:prstGeom prst="round1Rect">
+            <a:avLst>
+              <a:gd name="adj" fmla="val 16667"/>
+            </a:avLst>
+          </a:prstGeom>
+          <a:noFill/>
+          <a:ln w="9525" cap="flat" cmpd="sng">
+            <a:solidFill>
+              <a:schemeClr val="lt2"/>
+            </a:solidFill>
+            <a:prstDash val="solid"/>
+            <a:round/>
+            <a:headEnd type="none" w="sm" len="sm"/>
+            <a:tailEnd type="none" w="sm" len="sm"/>
+          </a:ln>
+        </p:spPr>
+        <p:txBody>
+          <a:bodyPr spcFirstLastPara="1" wrap="square" lIns="91425" tIns="91425" rIns="91425" bIns="91425" anchor="ctr" anchorCtr="0">
+            <a:noAutofit/>
+          </a:bodyPr>
+          <a:lstStyle/>
+          <a:p>
+            <a:pPr marL="0" lvl="0" indent="0" algn="ctr" rtl="0">
+              <a:spcBef>
+                <a:spcPts val="0"/>
+              </a:spcBef>
+              <a:spcAft>
+                <a:spcPts val="0"/>
+              </a:spcAft>
+              <a:buNone/>
+            </a:pPr>
+            <a:endParaRPr>
+              <a:latin typeface="Maven Pro"/>
+              <a:ea typeface="Maven Pro"/>
+              <a:cs typeface="Maven Pro"/>
+              <a:sym typeface="Maven Pro"/>
+            </a:endParaRPr>
+          </a:p>
+        </p:txBody>
+      </p:sp>
     </p:spTree>
   </p:cSld>
   <p:clrMapOvr>
@@ -40433,8 +40484,8 @@
         </p:nvSpPr>
         <p:spPr>
           <a:xfrm>
-            <a:off x="722375" y="1320036"/>
-            <a:ext cx="2389800" cy="3052584"/>
+            <a:off x="540000" y="1320036"/>
+            <a:ext cx="2448000" cy="3052584"/>
           </a:xfrm>
           <a:prstGeom prst="rect">
             <a:avLst/>
@@ -40478,8 +40529,8 @@
         </p:nvSpPr>
         <p:spPr>
           <a:xfrm>
-            <a:off x="3377075" y="1320036"/>
-            <a:ext cx="2389800" cy="3052584"/>
+            <a:off x="3528000" y="1320036"/>
+            <a:ext cx="2448000" cy="3052584"/>
           </a:xfrm>
           <a:prstGeom prst="rect">
             <a:avLst/>
@@ -40765,8 +40816,8 @@
         </p:nvSpPr>
         <p:spPr>
           <a:xfrm>
-            <a:off x="6127969" y="1320036"/>
-            <a:ext cx="2389800" cy="3052584"/>
+            <a:off x="6516000" y="1320036"/>
+            <a:ext cx="2160000" cy="3052584"/>
           </a:xfrm>
           <a:prstGeom prst="rect">
             <a:avLst/>
@@ -41113,6 +41164,44 @@
           <a:xfrm>
             <a:off x="852523" y="1340662"/>
             <a:ext cx="6909564" cy="1381912"/>
+          </a:xfrm>
+          <a:prstGeom prst="rect">
+            <a:avLst/>
+          </a:prstGeom>
+        </p:spPr>
+        <p:txBody>
+          <a:bodyPr spcFirstLastPara="1" wrap="square" lIns="91425" tIns="91425" rIns="91425" bIns="91425" anchor="t" anchorCtr="0">
+            <a:noAutofit/>
+          </a:bodyPr>
+          <a:lstStyle/>
+          <a:p>
+            <a:pPr marL="0" lvl="0" indent="0" algn="l" rtl="0">
+              <a:spcBef>
+                <a:spcPts val="0"/>
+              </a:spcBef>
+              <a:spcAft>
+                <a:spcPts val="0"/>
+              </a:spcAft>
+              <a:buNone/>
+            </a:pPr>
+            <a:endParaRPr dirty="0"/>
+          </a:p>
+        </p:txBody>
+      </p:sp>
+      <p:sp>
+        <p:nvSpPr>
+          <p:cNvPr id="1200" name="Google Shape;1200;p47"/>
+          <p:cNvSpPr txBox="1">
+            <a:spLocks noGrp="1"/>
+          </p:cNvSpPr>
+          <p:nvPr>
+            <p:ph type="subTitle" idx="6"/>
+          </p:nvPr>
+        </p:nvSpPr>
+        <p:spPr>
+          <a:xfrm>
+            <a:off x="2464053" y="2960520"/>
+            <a:ext cx="5298033" cy="1494601"/>
           </a:xfrm>
           <a:prstGeom prst="rect">
             <a:avLst/>

</xml_diff>